<commit_message>
New system. A lot of updates
</commit_message>
<xml_diff>
--- a/Inventory layout.pptx
+++ b/Inventory layout.pptx
@@ -3408,8 +3408,8 @@
           </p:nvSpPr>
           <p:spPr>
             <a:xfrm>
-              <a:off x="7614249" y="1566495"/>
-              <a:ext cx="2949836" cy="369332"/>
+              <a:off x="8420209" y="1438519"/>
+              <a:ext cx="1486322" cy="369332"/>
             </a:xfrm>
             <a:prstGeom prst="rect">
               <a:avLst/>
@@ -3424,7 +3424,7 @@
             <a:p>
               <a:r>
                 <a:rPr lang="en-US" dirty="0"/>
-                <a:t>Command bridge</a:t>
+                <a:t>Cockpit</a:t>
               </a:r>
             </a:p>
           </p:txBody>

</xml_diff>